<commit_message>
Apresentação atualizada com as telas da versão 1.4
Co-authored-by: Bradley iDesign <bradleylukka@gmail.com>
</commit_message>
<xml_diff>
--- a/CuidarApp/docs/apresentacao/CuidarApp_Apresentacao.pptx
+++ b/CuidarApp/docs/apresentacao/CuidarApp_Apresentacao.pptx
@@ -3453,7 +3453,7 @@
                 </a:solidFill>
                 <a:latin typeface="Calibri"/>
               </a:rPr>
-              <a:t>Apresentação de funcionalidades • Versão 1.3</a:t>
+              <a:t>Apresentação de funcionalidades • Versão 1.4</a:t>
             </a:r>
           </a:p>
         </p:txBody>
@@ -3660,7 +3660,7 @@
       </p:sp>
       <p:pic>
         <p:nvPicPr>
-          <p:cNvPr id="5" name="Picture 4" descr="13-cuidador-semana.png"/>
+          <p:cNvPr id="5" name="Picture 4" descr="12-cuidador-progresso.png"/>
           <p:cNvPicPr>
             <a:picLocks noChangeAspect="1"/>
           </p:cNvPicPr>
@@ -5231,7 +5231,7 @@
                 </a:solidFill>
                 <a:latin typeface="Calibri"/>
               </a:rPr>
-              <a:t>Café, almoço, lanche e jantar por dia, com botão para copiar o cardápio para a semana toda.</a:t>
+              <a:t>Café, almoço, lanche e jantar por dia, salvos automaticamente, com opção de copiar o cardápio para a semana toda.</a:t>
             </a:r>
           </a:p>
         </p:txBody>
@@ -5409,7 +5409,7 @@
                 </a:solidFill>
                 <a:latin typeface="Calibri"/>
               </a:rPr>
-              <a:t>Exemplos de alimentos proteicos e meta diária no topo da dieta.</a:t>
+              <a:t>Exemplos de alimentos proteicos e meta diária junto da dieta.</a:t>
             </a:r>
           </a:p>
         </p:txBody>
@@ -7877,7 +7877,7 @@
                 </a:solidFill>
                 <a:latin typeface="Calibri"/>
               </a:rPr>
-              <a:t>Também corrigido: edição de nomes, senha e telefones (o WebView não exibia as janelas antigas), botão voltar do Android, visitas do dia e navegação inferior.</a:t>
+              <a:t>Também corrigido: menu inferior funcional e sem duplicidades, edição de nomes, senha e telefones, check-in de humor, botão voltar do Android e visual com bordas mais leves.</a:t>
             </a:r>
           </a:p>
         </p:txBody>
@@ -16542,7 +16542,7 @@
                 </a:solidFill>
                 <a:latin typeface="Calibri"/>
               </a:rPr>
-              <a:t>Saudação pelo horário, data por extenso e categorias grandes para navegar.</a:t>
+              <a:t>Saudação pelo horário, data por extenso e um menu inferior simples: Hoje, Remédios, Exercícios, Comida e Humor.</a:t>
             </a:r>
           </a:p>
         </p:txBody>
@@ -20290,7 +20290,7 @@
                 </a:solidFill>
                 <a:latin typeface="Calibri"/>
               </a:rPr>
-              <a:t>Botão central na barra inferior: liga para o 192 ou direto para o cuidador.</a:t>
+              <a:t>Botão vermelho no topo de todas as telas do idoso: liga para o 192 ou direto para o cuidador.</a:t>
             </a:r>
           </a:p>
         </p:txBody>
@@ -20526,7 +20526,7 @@
                 </a:solidFill>
                 <a:latin typeface="Calibri"/>
               </a:rPr>
-              <a:t>Visão do dia em segundos: alertas, ações rápidas e progresso.</a:t>
+              <a:t>Visão do dia em segundos: alertas, progresso de hoje e semana.</a:t>
             </a:r>
           </a:p>
         </p:txBody>
@@ -20888,7 +20888,7 @@
                 </a:solidFill>
                 <a:latin typeface="Calibri"/>
               </a:rPr>
-              <a:t>Ações rápidas</a:t>
+              <a:t>Menu por área</a:t>
             </a:r>
           </a:p>
         </p:txBody>
@@ -20930,7 +20930,7 @@
                 </a:solidFill>
                 <a:latin typeface="Calibri"/>
               </a:rPr>
-              <a:t>Cadastrar medicamento, exercício, visita ou editar a dieta em um toque.</a:t>
+              <a:t>Painel, Remédios, Exercícios, Dieta e Visitas na barra inferior; configurações na engrenagem do topo.</a:t>
             </a:r>
           </a:p>
         </p:txBody>

</xml_diff>